<commit_message>
Rename StratOS to the Strat-IQ Toolkit and relicense: PolyForm Noncommercial (code) and CC BY-NC 4.0 (content)
Skill IDs move from stratos-* to stratiq-*. Commercial licences: BScheller@ToolsIQ.ai.

Co-Authored-By: Claude Opus 5.5 <noreply@anthropic.com>
Claude-Session: https://claude.ai/code/session_01X5wRPLvDNAfKFFNbzhL7V8
</commit_message>
<xml_diff>
--- a/demo/globus/weekly-report-Y7-deck.pptx
+++ b/demo/globus/weekly-report-Y7-deck.pptx
@@ -4279,7 +4279,7 @@
                 </a:solidFill>
                 <a:latin typeface="Calibri"/>
               </a:rPr>
-              <a:t>STRATOS GLO-BUS WEEKLY REVIEW</a:t>
+              <a:t>STRAT-IQ GLO-BUS WEEKLY REVIEW</a:t>
             </a:r>
           </a:p>
         </p:txBody>
@@ -4392,7 +4392,7 @@
                 </a:solidFill>
                 <a:latin typeface="Calibri"/>
               </a:rPr>
-              <a:t>Source: GLO-BUS captures, Years 6–7 (company reports, class scoreboard, Competitive Intelligence Report); StratOS weekly_report.py</a:t>
+              <a:t>Source: GLO-BUS captures, Years 6–7 (company reports, class scoreboard, Competitive Intelligence Report); Strat-IQ weekly_report.py</a:t>
             </a:r>
           </a:p>
         </p:txBody>
@@ -4478,7 +4478,7 @@
                 </a:solidFill>
                 <a:latin typeface="Calibri"/>
               </a:rPr>
-              <a:t>Source: GLO-BUS captures, Years 6–7 (company reports, class scoreboard, Competitive Intelligence Report); StratOS weekly_report.py</a:t>
+              <a:t>Source: GLO-BUS captures, Years 6–7 (company reports, class scoreboard, Competitive Intelligence Report); Strat-IQ weekly_report.py</a:t>
             </a:r>
           </a:p>
         </p:txBody>
@@ -5200,7 +5200,7 @@
                 </a:solidFill>
                 <a:latin typeface="Calibri"/>
               </a:rPr>
-              <a:t>Source: GLO-BUS captures, Years 6–7 (company reports, class scoreboard, Competitive Intelligence Report); StratOS weekly_report.py</a:t>
+              <a:t>Source: GLO-BUS captures, Years 6–7 (company reports, class scoreboard, Competitive Intelligence Report); Strat-IQ weekly_report.py</a:t>
             </a:r>
           </a:p>
         </p:txBody>
@@ -5868,7 +5868,7 @@
                 </a:solidFill>
                 <a:latin typeface="Calibri"/>
               </a:rPr>
-              <a:t>Source: GLO-BUS captures, Years 6–7 (company reports, class scoreboard, Competitive Intelligence Report); StratOS weekly_report.py</a:t>
+              <a:t>Source: GLO-BUS captures, Years 6–7 (company reports, class scoreboard, Competitive Intelligence Report); Strat-IQ weekly_report.py</a:t>
             </a:r>
           </a:p>
         </p:txBody>
@@ -5978,7 +5978,7 @@
                 </a:solidFill>
                 <a:latin typeface="Calibri"/>
               </a:rPr>
-              <a:t>Source: GLO-BUS captures, Years 6–7 (company reports, class scoreboard, Competitive Intelligence Report); StratOS weekly_report.py</a:t>
+              <a:t>Source: GLO-BUS captures, Years 6–7 (company reports, class scoreboard, Competitive Intelligence Report); Strat-IQ weekly_report.py</a:t>
             </a:r>
           </a:p>
         </p:txBody>
@@ -6112,7 +6112,7 @@
                 </a:solidFill>
                 <a:latin typeface="Calibri"/>
               </a:rPr>
-              <a:t>Source: GLO-BUS captures, Years 6–7 (company reports, class scoreboard, Competitive Intelligence Report); StratOS weekly_report.py</a:t>
+              <a:t>Source: GLO-BUS captures, Years 6–7 (company reports, class scoreboard, Competitive Intelligence Report); Strat-IQ weekly_report.py</a:t>
             </a:r>
           </a:p>
         </p:txBody>
@@ -6363,7 +6363,7 @@
                 </a:solidFill>
                 <a:latin typeface="Calibri"/>
               </a:rPr>
-              <a:t>Source: GLO-BUS captures, Years 6–7 (company reports, class scoreboard, Competitive Intelligence Report); StratOS weekly_report.py</a:t>
+              <a:t>Source: GLO-BUS captures, Years 6–7 (company reports, class scoreboard, Competitive Intelligence Report); Strat-IQ weekly_report.py</a:t>
             </a:r>
           </a:p>
         </p:txBody>
@@ -7000,7 +7000,7 @@
                 </a:solidFill>
                 <a:latin typeface="Calibri"/>
               </a:rPr>
-              <a:t>Source: GLO-BUS captures, Years 6–7 (company reports, class scoreboard, Competitive Intelligence Report); StratOS weekly_report.py</a:t>
+              <a:t>Source: GLO-BUS captures, Years 6–7 (company reports, class scoreboard, Competitive Intelligence Report); Strat-IQ weekly_report.py</a:t>
             </a:r>
           </a:p>
         </p:txBody>
@@ -7918,7 +7918,7 @@
                 </a:solidFill>
                 <a:latin typeface="Calibri"/>
               </a:rPr>
-              <a:t>Source: GLO-BUS captures, Years 6–7 (company reports, class scoreboard, Competitive Intelligence Report); StratOS weekly_report.py</a:t>
+              <a:t>Source: GLO-BUS captures, Years 6–7 (company reports, class scoreboard, Competitive Intelligence Report); Strat-IQ weekly_report.py</a:t>
             </a:r>
           </a:p>
         </p:txBody>

</xml_diff>